<commit_message>
refine training script - chain model
</commit_message>
<xml_diff>
--- a/1.training_model/slide_presentation/Device Identifier 20260414.pptx
+++ b/1.training_model/slide_presentation/Device Identifier 20260414.pptx
@@ -209,7 +209,7 @@
           <a:p>
             <a:fld id="{23D8B80A-F233-4240-BDAF-6537AE249829}" type="datetimeFigureOut">
               <a:rPr lang="en-MY" smtClean="0"/>
-              <a:t>20/4/2026</a:t>
+              <a:t>23/4/2026</a:t>
             </a:fld>
             <a:endParaRPr lang="en-MY"/>
           </a:p>
@@ -1920,7 +1920,7 @@
           <a:p>
             <a:fld id="{1CD01395-AC05-405C-BAB9-E5D2B9FDBB40}" type="datetimeFigureOut">
               <a:rPr lang="en-MY" smtClean="0"/>
-              <a:t>20/4/2026</a:t>
+              <a:t>23/4/2026</a:t>
             </a:fld>
             <a:endParaRPr lang="en-MY"/>
           </a:p>
@@ -2235,7 +2235,7 @@
           <a:p>
             <a:fld id="{1CD01395-AC05-405C-BAB9-E5D2B9FDBB40}" type="datetimeFigureOut">
               <a:rPr lang="en-MY" smtClean="0"/>
-              <a:t>20/4/2026</a:t>
+              <a:t>23/4/2026</a:t>
             </a:fld>
             <a:endParaRPr lang="en-MY"/>
           </a:p>
@@ -2457,7 +2457,7 @@
           <a:p>
             <a:fld id="{1CD01395-AC05-405C-BAB9-E5D2B9FDBB40}" type="datetimeFigureOut">
               <a:rPr lang="en-MY" smtClean="0"/>
-              <a:t>20/4/2026</a:t>
+              <a:t>23/4/2026</a:t>
             </a:fld>
             <a:endParaRPr lang="en-MY"/>
           </a:p>
@@ -2748,7 +2748,7 @@
           <a:p>
             <a:fld id="{1CD01395-AC05-405C-BAB9-E5D2B9FDBB40}" type="datetimeFigureOut">
               <a:rPr lang="en-MY" smtClean="0"/>
-              <a:t>20/4/2026</a:t>
+              <a:t>23/4/2026</a:t>
             </a:fld>
             <a:endParaRPr lang="en-MY"/>
           </a:p>
@@ -3202,7 +3202,7 @@
           <a:p>
             <a:fld id="{1CD01395-AC05-405C-BAB9-E5D2B9FDBB40}" type="datetimeFigureOut">
               <a:rPr lang="en-MY" smtClean="0"/>
-              <a:t>20/4/2026</a:t>
+              <a:t>23/4/2026</a:t>
             </a:fld>
             <a:endParaRPr lang="en-MY"/>
           </a:p>
@@ -3778,7 +3778,7 @@
           <a:p>
             <a:fld id="{1CD01395-AC05-405C-BAB9-E5D2B9FDBB40}" type="datetimeFigureOut">
               <a:rPr lang="en-MY" smtClean="0"/>
-              <a:t>20/4/2026</a:t>
+              <a:t>23/4/2026</a:t>
             </a:fld>
             <a:endParaRPr lang="en-MY"/>
           </a:p>
@@ -4639,7 +4639,7 @@
           <a:p>
             <a:fld id="{1CD01395-AC05-405C-BAB9-E5D2B9FDBB40}" type="datetimeFigureOut">
               <a:rPr lang="en-MY" smtClean="0"/>
-              <a:t>20/4/2026</a:t>
+              <a:t>23/4/2026</a:t>
             </a:fld>
             <a:endParaRPr lang="en-MY"/>
           </a:p>
@@ -4844,7 +4844,7 @@
           <a:p>
             <a:fld id="{1CD01395-AC05-405C-BAB9-E5D2B9FDBB40}" type="datetimeFigureOut">
               <a:rPr lang="en-MY" smtClean="0"/>
-              <a:t>20/4/2026</a:t>
+              <a:t>23/4/2026</a:t>
             </a:fld>
             <a:endParaRPr lang="en-MY"/>
           </a:p>
@@ -5058,7 +5058,7 @@
           <a:p>
             <a:fld id="{1CD01395-AC05-405C-BAB9-E5D2B9FDBB40}" type="datetimeFigureOut">
               <a:rPr lang="en-MY" smtClean="0"/>
-              <a:t>20/4/2026</a:t>
+              <a:t>23/4/2026</a:t>
             </a:fld>
             <a:endParaRPr lang="en-MY"/>
           </a:p>
@@ -5263,7 +5263,7 @@
           <a:p>
             <a:fld id="{1CD01395-AC05-405C-BAB9-E5D2B9FDBB40}" type="datetimeFigureOut">
               <a:rPr lang="en-MY" smtClean="0"/>
-              <a:t>20/4/2026</a:t>
+              <a:t>23/4/2026</a:t>
             </a:fld>
             <a:endParaRPr lang="en-MY"/>
           </a:p>
@@ -5543,7 +5543,7 @@
           <a:p>
             <a:fld id="{1CD01395-AC05-405C-BAB9-E5D2B9FDBB40}" type="datetimeFigureOut">
               <a:rPr lang="en-MY" smtClean="0"/>
-              <a:t>20/4/2026</a:t>
+              <a:t>23/4/2026</a:t>
             </a:fld>
             <a:endParaRPr lang="en-MY"/>
           </a:p>
@@ -5810,7 +5810,7 @@
           <a:p>
             <a:fld id="{1CD01395-AC05-405C-BAB9-E5D2B9FDBB40}" type="datetimeFigureOut">
               <a:rPr lang="en-MY" smtClean="0"/>
-              <a:t>20/4/2026</a:t>
+              <a:t>23/4/2026</a:t>
             </a:fld>
             <a:endParaRPr lang="en-MY"/>
           </a:p>
@@ -6225,7 +6225,7 @@
           <a:p>
             <a:fld id="{1CD01395-AC05-405C-BAB9-E5D2B9FDBB40}" type="datetimeFigureOut">
               <a:rPr lang="en-MY" smtClean="0"/>
-              <a:t>20/4/2026</a:t>
+              <a:t>23/4/2026</a:t>
             </a:fld>
             <a:endParaRPr lang="en-MY"/>
           </a:p>
@@ -6373,7 +6373,7 @@
           <a:p>
             <a:fld id="{1CD01395-AC05-405C-BAB9-E5D2B9FDBB40}" type="datetimeFigureOut">
               <a:rPr lang="en-MY" smtClean="0"/>
-              <a:t>20/4/2026</a:t>
+              <a:t>23/4/2026</a:t>
             </a:fld>
             <a:endParaRPr lang="en-MY"/>
           </a:p>
@@ -6498,7 +6498,7 @@
           <a:p>
             <a:fld id="{1CD01395-AC05-405C-BAB9-E5D2B9FDBB40}" type="datetimeFigureOut">
               <a:rPr lang="en-MY" smtClean="0"/>
-              <a:t>20/4/2026</a:t>
+              <a:t>23/4/2026</a:t>
             </a:fld>
             <a:endParaRPr lang="en-MY"/>
           </a:p>
@@ -6777,7 +6777,7 @@
           <a:p>
             <a:fld id="{1CD01395-AC05-405C-BAB9-E5D2B9FDBB40}" type="datetimeFigureOut">
               <a:rPr lang="en-MY" smtClean="0"/>
-              <a:t>20/4/2026</a:t>
+              <a:t>23/4/2026</a:t>
             </a:fld>
             <a:endParaRPr lang="en-MY"/>
           </a:p>
@@ -7092,7 +7092,7 @@
           <a:p>
             <a:fld id="{1CD01395-AC05-405C-BAB9-E5D2B9FDBB40}" type="datetimeFigureOut">
               <a:rPr lang="en-MY" smtClean="0"/>
-              <a:t>20/4/2026</a:t>
+              <a:t>23/4/2026</a:t>
             </a:fld>
             <a:endParaRPr lang="en-MY"/>
           </a:p>
@@ -7345,7 +7345,7 @@
           <a:p>
             <a:fld id="{1CD01395-AC05-405C-BAB9-E5D2B9FDBB40}" type="datetimeFigureOut">
               <a:rPr lang="en-MY" smtClean="0"/>
-              <a:t>20/4/2026</a:t>
+              <a:t>23/4/2026</a:t>
             </a:fld>
             <a:endParaRPr lang="en-MY"/>
           </a:p>
@@ -10539,6 +10539,36 @@
           <a:chExt cx="0" cy="0"/>
         </a:xfrm>
       </p:grpSpPr>
+      <p:pic>
+        <p:nvPicPr>
+          <p:cNvPr id="3" name="Picture 2">
+            <a:extLst>
+              <a:ext uri="{FF2B5EF4-FFF2-40B4-BE49-F238E27FC236}">
+                <a16:creationId xmlns:a16="http://schemas.microsoft.com/office/drawing/2014/main" id="{1582A625-0A36-5DBD-23AD-272844215260}"/>
+              </a:ext>
+            </a:extLst>
+          </p:cNvPr>
+          <p:cNvPicPr>
+            <a:picLocks noChangeAspect="1"/>
+          </p:cNvPicPr>
+          <p:nvPr/>
+        </p:nvPicPr>
+        <p:blipFill>
+          <a:blip r:embed="rId3"/>
+          <a:stretch>
+            <a:fillRect/>
+          </a:stretch>
+        </p:blipFill>
+        <p:spPr>
+          <a:xfrm>
+            <a:off x="1219200" y="442912"/>
+            <a:ext cx="9753600" cy="5972175"/>
+          </a:xfrm>
+          <a:prstGeom prst="rect">
+            <a:avLst/>
+          </a:prstGeom>
+        </p:spPr>
+      </p:pic>
     </p:spTree>
     <p:extLst>
       <p:ext uri="{BB962C8B-B14F-4D97-AF65-F5344CB8AC3E}">

</xml_diff>

<commit_message>
refine and update - application script
</commit_message>
<xml_diff>
--- a/1.training_model/slide_presentation/Device Identifier 20260414.pptx
+++ b/1.training_model/slide_presentation/Device Identifier 20260414.pptx
@@ -5,7 +5,7 @@
     <p:sldMasterId id="2147483696" r:id="rId1"/>
   </p:sldMasterIdLst>
   <p:notesMasterIdLst>
-    <p:notesMasterId r:id="rId21"/>
+    <p:notesMasterId r:id="rId22"/>
   </p:notesMasterIdLst>
   <p:sldIdLst>
     <p:sldId id="256" r:id="rId2"/>
@@ -14,19 +14,20 @@
     <p:sldId id="324" r:id="rId5"/>
     <p:sldId id="326" r:id="rId6"/>
     <p:sldId id="325" r:id="rId7"/>
-    <p:sldId id="330" r:id="rId8"/>
-    <p:sldId id="329" r:id="rId9"/>
-    <p:sldId id="328" r:id="rId10"/>
-    <p:sldId id="327" r:id="rId11"/>
-    <p:sldId id="322" r:id="rId12"/>
-    <p:sldId id="321" r:id="rId13"/>
-    <p:sldId id="308" r:id="rId14"/>
-    <p:sldId id="318" r:id="rId15"/>
-    <p:sldId id="319" r:id="rId16"/>
-    <p:sldId id="315" r:id="rId17"/>
-    <p:sldId id="317" r:id="rId18"/>
-    <p:sldId id="313" r:id="rId19"/>
-    <p:sldId id="316" r:id="rId20"/>
+    <p:sldId id="332" r:id="rId8"/>
+    <p:sldId id="330" r:id="rId9"/>
+    <p:sldId id="329" r:id="rId10"/>
+    <p:sldId id="328" r:id="rId11"/>
+    <p:sldId id="327" r:id="rId12"/>
+    <p:sldId id="322" r:id="rId13"/>
+    <p:sldId id="321" r:id="rId14"/>
+    <p:sldId id="308" r:id="rId15"/>
+    <p:sldId id="318" r:id="rId16"/>
+    <p:sldId id="319" r:id="rId17"/>
+    <p:sldId id="315" r:id="rId18"/>
+    <p:sldId id="317" r:id="rId19"/>
+    <p:sldId id="313" r:id="rId20"/>
+    <p:sldId id="316" r:id="rId21"/>
   </p:sldIdLst>
   <p:sldSz cx="12192000" cy="6858000"/>
   <p:notesSz cx="6858000" cy="9144000"/>
@@ -215,7 +216,7 @@
           <a:p>
             <a:fld id="{23D8B80A-F233-4240-BDAF-6537AE249829}" type="datetimeFigureOut">
               <a:rPr lang="en-MY" smtClean="0"/>
-              <a:t>6/5/2026</a:t>
+              <a:t>7/5/2026</a:t>
             </a:fld>
             <a:endParaRPr lang="en-MY"/>
           </a:p>
@@ -575,6 +576,114 @@
         <p:cNvPr id="1" name="">
           <a:extLst>
             <a:ext uri="{FF2B5EF4-FFF2-40B4-BE49-F238E27FC236}">
+              <a16:creationId xmlns:a16="http://schemas.microsoft.com/office/drawing/2014/main" id="{CD65CC31-DDBD-A83E-77AD-73DD9EA7AADA}"/>
+            </a:ext>
+          </a:extLst>
+        </p:cNvPr>
+        <p:cNvGrpSpPr/>
+        <p:nvPr/>
+      </p:nvGrpSpPr>
+      <p:grpSpPr>
+        <a:xfrm>
+          <a:off x="0" y="0"/>
+          <a:ext cx="0" cy="0"/>
+          <a:chOff x="0" y="0"/>
+          <a:chExt cx="0" cy="0"/>
+        </a:xfrm>
+      </p:grpSpPr>
+      <p:sp>
+        <p:nvSpPr>
+          <p:cNvPr id="2" name="Slide Image Placeholder 1">
+            <a:extLst>
+              <a:ext uri="{FF2B5EF4-FFF2-40B4-BE49-F238E27FC236}">
+                <a16:creationId xmlns:a16="http://schemas.microsoft.com/office/drawing/2014/main" id="{75A6BE32-AD46-3994-D2B5-596BFA4482B9}"/>
+              </a:ext>
+            </a:extLst>
+          </p:cNvPr>
+          <p:cNvSpPr>
+            <a:spLocks noGrp="1" noRot="1" noChangeAspect="1"/>
+          </p:cNvSpPr>
+          <p:nvPr>
+            <p:ph type="sldImg"/>
+          </p:nvPr>
+        </p:nvSpPr>
+        <p:spPr/>
+      </p:sp>
+      <p:sp>
+        <p:nvSpPr>
+          <p:cNvPr id="3" name="Notes Placeholder 2">
+            <a:extLst>
+              <a:ext uri="{FF2B5EF4-FFF2-40B4-BE49-F238E27FC236}">
+                <a16:creationId xmlns:a16="http://schemas.microsoft.com/office/drawing/2014/main" id="{2DD8584B-F663-50AD-7BAD-29E261633728}"/>
+              </a:ext>
+            </a:extLst>
+          </p:cNvPr>
+          <p:cNvSpPr>
+            <a:spLocks noGrp="1"/>
+          </p:cNvSpPr>
+          <p:nvPr>
+            <p:ph type="body" idx="1"/>
+          </p:nvPr>
+        </p:nvSpPr>
+        <p:spPr/>
+        <p:txBody>
+          <a:bodyPr/>
+          <a:lstStyle/>
+          <a:p>
+            <a:endParaRPr lang="en-MY" dirty="0"/>
+          </a:p>
+        </p:txBody>
+      </p:sp>
+      <p:sp>
+        <p:nvSpPr>
+          <p:cNvPr id="4" name="Slide Number Placeholder 3">
+            <a:extLst>
+              <a:ext uri="{FF2B5EF4-FFF2-40B4-BE49-F238E27FC236}">
+                <a16:creationId xmlns:a16="http://schemas.microsoft.com/office/drawing/2014/main" id="{0A1087DB-E39A-687F-05EB-96BC857E8EC2}"/>
+              </a:ext>
+            </a:extLst>
+          </p:cNvPr>
+          <p:cNvSpPr>
+            <a:spLocks noGrp="1"/>
+          </p:cNvSpPr>
+          <p:nvPr>
+            <p:ph type="sldNum" sz="quarter" idx="5"/>
+          </p:nvPr>
+        </p:nvSpPr>
+        <p:spPr/>
+        <p:txBody>
+          <a:bodyPr/>
+          <a:lstStyle/>
+          <a:p>
+            <a:fld id="{D16833E0-5E66-4D1D-89F5-BD860FDD8F71}" type="slidenum">
+              <a:rPr lang="en-MY" smtClean="0"/>
+              <a:t>11</a:t>
+            </a:fld>
+            <a:endParaRPr lang="en-MY"/>
+          </a:p>
+        </p:txBody>
+      </p:sp>
+    </p:spTree>
+    <p:extLst>
+      <p:ext uri="{BB962C8B-B14F-4D97-AF65-F5344CB8AC3E}">
+        <p14:creationId xmlns:p14="http://schemas.microsoft.com/office/powerpoint/2010/main" val="1599132718"/>
+      </p:ext>
+    </p:extLst>
+  </p:cSld>
+  <p:clrMapOvr>
+    <a:masterClrMapping/>
+  </p:clrMapOvr>
+</p:notes>
+</file>
+
+<file path=ppt/notesSlides/notesSlide11.xml><?xml version="1.0" encoding="utf-8"?>
+<p:notes xmlns:a="http://schemas.openxmlformats.org/drawingml/2006/main" xmlns:r="http://schemas.openxmlformats.org/officeDocument/2006/relationships" xmlns:p="http://schemas.openxmlformats.org/presentationml/2006/main">
+  <p:cSld>
+    <p:spTree>
+      <p:nvGrpSpPr>
+        <p:cNvPr id="1" name="">
+          <a:extLst>
+            <a:ext uri="{FF2B5EF4-FFF2-40B4-BE49-F238E27FC236}">
               <a16:creationId xmlns:a16="http://schemas.microsoft.com/office/drawing/2014/main" id="{760B0DA3-B6BD-4EFE-90F9-176D4D36867B}"/>
             </a:ext>
           </a:extLst>
@@ -656,7 +765,7 @@
           <a:p>
             <a:fld id="{D16833E0-5E66-4D1D-89F5-BD860FDD8F71}" type="slidenum">
               <a:rPr lang="en-MY" smtClean="0"/>
-              <a:t>11</a:t>
+              <a:t>12</a:t>
             </a:fld>
             <a:endParaRPr lang="en-MY"/>
           </a:p>
@@ -675,7 +784,7 @@
 </p:notes>
 </file>
 
-<file path=ppt/notesSlides/notesSlide11.xml><?xml version="1.0" encoding="utf-8"?>
+<file path=ppt/notesSlides/notesSlide12.xml><?xml version="1.0" encoding="utf-8"?>
 <p:notes xmlns:a="http://schemas.openxmlformats.org/drawingml/2006/main" xmlns:r="http://schemas.openxmlformats.org/officeDocument/2006/relationships" xmlns:p="http://schemas.openxmlformats.org/presentationml/2006/main">
   <p:cSld>
     <p:spTree>
@@ -764,7 +873,7 @@
           <a:p>
             <a:fld id="{D16833E0-5E66-4D1D-89F5-BD860FDD8F71}" type="slidenum">
               <a:rPr lang="en-MY" smtClean="0"/>
-              <a:t>12</a:t>
+              <a:t>13</a:t>
             </a:fld>
             <a:endParaRPr lang="en-MY"/>
           </a:p>
@@ -783,7 +892,7 @@
 </p:notes>
 </file>
 
-<file path=ppt/notesSlides/notesSlide12.xml><?xml version="1.0" encoding="utf-8"?>
+<file path=ppt/notesSlides/notesSlide13.xml><?xml version="1.0" encoding="utf-8"?>
 <p:notes xmlns:a="http://schemas.openxmlformats.org/drawingml/2006/main" xmlns:r="http://schemas.openxmlformats.org/officeDocument/2006/relationships" xmlns:p="http://schemas.openxmlformats.org/presentationml/2006/main">
   <p:cSld>
     <p:spTree>
@@ -872,7 +981,7 @@
           <a:p>
             <a:fld id="{D16833E0-5E66-4D1D-89F5-BD860FDD8F71}" type="slidenum">
               <a:rPr lang="en-MY" smtClean="0"/>
-              <a:t>13</a:t>
+              <a:t>14</a:t>
             </a:fld>
             <a:endParaRPr lang="en-MY"/>
           </a:p>
@@ -891,7 +1000,7 @@
 </p:notes>
 </file>
 
-<file path=ppt/notesSlides/notesSlide13.xml><?xml version="1.0" encoding="utf-8"?>
+<file path=ppt/notesSlides/notesSlide14.xml><?xml version="1.0" encoding="utf-8"?>
 <p:notes xmlns:a="http://schemas.openxmlformats.org/drawingml/2006/main" xmlns:r="http://schemas.openxmlformats.org/officeDocument/2006/relationships" xmlns:p="http://schemas.openxmlformats.org/presentationml/2006/main">
   <p:cSld>
     <p:spTree>
@@ -980,7 +1089,7 @@
           <a:p>
             <a:fld id="{D16833E0-5E66-4D1D-89F5-BD860FDD8F71}" type="slidenum">
               <a:rPr lang="en-MY" smtClean="0"/>
-              <a:t>14</a:t>
+              <a:t>15</a:t>
             </a:fld>
             <a:endParaRPr lang="en-MY"/>
           </a:p>
@@ -999,7 +1108,7 @@
 </p:notes>
 </file>
 
-<file path=ppt/notesSlides/notesSlide14.xml><?xml version="1.0" encoding="utf-8"?>
+<file path=ppt/notesSlides/notesSlide15.xml><?xml version="1.0" encoding="utf-8"?>
 <p:notes xmlns:a="http://schemas.openxmlformats.org/drawingml/2006/main" xmlns:r="http://schemas.openxmlformats.org/officeDocument/2006/relationships" xmlns:p="http://schemas.openxmlformats.org/presentationml/2006/main">
   <p:cSld>
     <p:spTree>
@@ -1088,7 +1197,7 @@
           <a:p>
             <a:fld id="{D16833E0-5E66-4D1D-89F5-BD860FDD8F71}" type="slidenum">
               <a:rPr lang="en-MY" smtClean="0"/>
-              <a:t>15</a:t>
+              <a:t>16</a:t>
             </a:fld>
             <a:endParaRPr lang="en-MY"/>
           </a:p>
@@ -1107,7 +1216,7 @@
 </p:notes>
 </file>
 
-<file path=ppt/notesSlides/notesSlide15.xml><?xml version="1.0" encoding="utf-8"?>
+<file path=ppt/notesSlides/notesSlide16.xml><?xml version="1.0" encoding="utf-8"?>
 <p:notes xmlns:a="http://schemas.openxmlformats.org/drawingml/2006/main" xmlns:r="http://schemas.openxmlformats.org/officeDocument/2006/relationships" xmlns:p="http://schemas.openxmlformats.org/presentationml/2006/main">
   <p:cSld>
     <p:spTree>
@@ -1196,7 +1305,7 @@
           <a:p>
             <a:fld id="{D16833E0-5E66-4D1D-89F5-BD860FDD8F71}" type="slidenum">
               <a:rPr lang="en-MY" smtClean="0"/>
-              <a:t>16</a:t>
+              <a:t>17</a:t>
             </a:fld>
             <a:endParaRPr lang="en-MY"/>
           </a:p>
@@ -1215,7 +1324,7 @@
 </p:notes>
 </file>
 
-<file path=ppt/notesSlides/notesSlide16.xml><?xml version="1.0" encoding="utf-8"?>
+<file path=ppt/notesSlides/notesSlide17.xml><?xml version="1.0" encoding="utf-8"?>
 <p:notes xmlns:a="http://schemas.openxmlformats.org/drawingml/2006/main" xmlns:r="http://schemas.openxmlformats.org/officeDocument/2006/relationships" xmlns:p="http://schemas.openxmlformats.org/presentationml/2006/main">
   <p:cSld>
     <p:spTree>
@@ -1304,7 +1413,7 @@
           <a:p>
             <a:fld id="{D16833E0-5E66-4D1D-89F5-BD860FDD8F71}" type="slidenum">
               <a:rPr lang="en-MY" smtClean="0"/>
-              <a:t>17</a:t>
+              <a:t>18</a:t>
             </a:fld>
             <a:endParaRPr lang="en-MY"/>
           </a:p>
@@ -1323,7 +1432,7 @@
 </p:notes>
 </file>
 
-<file path=ppt/notesSlides/notesSlide17.xml><?xml version="1.0" encoding="utf-8"?>
+<file path=ppt/notesSlides/notesSlide18.xml><?xml version="1.0" encoding="utf-8"?>
 <p:notes xmlns:a="http://schemas.openxmlformats.org/drawingml/2006/main" xmlns:r="http://schemas.openxmlformats.org/officeDocument/2006/relationships" xmlns:p="http://schemas.openxmlformats.org/presentationml/2006/main">
   <p:cSld>
     <p:spTree>
@@ -1412,7 +1521,7 @@
           <a:p>
             <a:fld id="{D16833E0-5E66-4D1D-89F5-BD860FDD8F71}" type="slidenum">
               <a:rPr lang="en-MY" smtClean="0"/>
-              <a:t>18</a:t>
+              <a:t>19</a:t>
             </a:fld>
             <a:endParaRPr lang="en-MY"/>
           </a:p>
@@ -1431,7 +1540,7 @@
 </p:notes>
 </file>
 
-<file path=ppt/notesSlides/notesSlide18.xml><?xml version="1.0" encoding="utf-8"?>
+<file path=ppt/notesSlides/notesSlide19.xml><?xml version="1.0" encoding="utf-8"?>
 <p:notes xmlns:a="http://schemas.openxmlformats.org/drawingml/2006/main" xmlns:r="http://schemas.openxmlformats.org/officeDocument/2006/relationships" xmlns:p="http://schemas.openxmlformats.org/presentationml/2006/main">
   <p:cSld>
     <p:spTree>
@@ -1520,7 +1629,7 @@
           <a:p>
             <a:fld id="{D16833E0-5E66-4D1D-89F5-BD860FDD8F71}" type="slidenum">
               <a:rPr lang="en-MY" smtClean="0"/>
-              <a:t>19</a:t>
+              <a:t>20</a:t>
             </a:fld>
             <a:endParaRPr lang="en-MY"/>
           </a:p>
@@ -1979,6 +2088,114 @@
         <p:cNvPr id="1" name="">
           <a:extLst>
             <a:ext uri="{FF2B5EF4-FFF2-40B4-BE49-F238E27FC236}">
+              <a16:creationId xmlns:a16="http://schemas.microsoft.com/office/drawing/2014/main" id="{490AA5E8-43DA-D62D-FB88-C294FC079058}"/>
+            </a:ext>
+          </a:extLst>
+        </p:cNvPr>
+        <p:cNvGrpSpPr/>
+        <p:nvPr/>
+      </p:nvGrpSpPr>
+      <p:grpSpPr>
+        <a:xfrm>
+          <a:off x="0" y="0"/>
+          <a:ext cx="0" cy="0"/>
+          <a:chOff x="0" y="0"/>
+          <a:chExt cx="0" cy="0"/>
+        </a:xfrm>
+      </p:grpSpPr>
+      <p:sp>
+        <p:nvSpPr>
+          <p:cNvPr id="2" name="Slide Image Placeholder 1">
+            <a:extLst>
+              <a:ext uri="{FF2B5EF4-FFF2-40B4-BE49-F238E27FC236}">
+                <a16:creationId xmlns:a16="http://schemas.microsoft.com/office/drawing/2014/main" id="{C45C137E-8AB1-3054-683E-73C9C0A71AE3}"/>
+              </a:ext>
+            </a:extLst>
+          </p:cNvPr>
+          <p:cNvSpPr>
+            <a:spLocks noGrp="1" noRot="1" noChangeAspect="1"/>
+          </p:cNvSpPr>
+          <p:nvPr>
+            <p:ph type="sldImg"/>
+          </p:nvPr>
+        </p:nvSpPr>
+        <p:spPr/>
+      </p:sp>
+      <p:sp>
+        <p:nvSpPr>
+          <p:cNvPr id="3" name="Notes Placeholder 2">
+            <a:extLst>
+              <a:ext uri="{FF2B5EF4-FFF2-40B4-BE49-F238E27FC236}">
+                <a16:creationId xmlns:a16="http://schemas.microsoft.com/office/drawing/2014/main" id="{F590523D-806B-67DF-85E6-BEE033FCCC56}"/>
+              </a:ext>
+            </a:extLst>
+          </p:cNvPr>
+          <p:cNvSpPr>
+            <a:spLocks noGrp="1"/>
+          </p:cNvSpPr>
+          <p:nvPr>
+            <p:ph type="body" idx="1"/>
+          </p:nvPr>
+        </p:nvSpPr>
+        <p:spPr/>
+        <p:txBody>
+          <a:bodyPr/>
+          <a:lstStyle/>
+          <a:p>
+            <a:endParaRPr lang="en-MY" dirty="0"/>
+          </a:p>
+        </p:txBody>
+      </p:sp>
+      <p:sp>
+        <p:nvSpPr>
+          <p:cNvPr id="4" name="Slide Number Placeholder 3">
+            <a:extLst>
+              <a:ext uri="{FF2B5EF4-FFF2-40B4-BE49-F238E27FC236}">
+                <a16:creationId xmlns:a16="http://schemas.microsoft.com/office/drawing/2014/main" id="{980BF987-8233-AB67-4586-17379D826862}"/>
+              </a:ext>
+            </a:extLst>
+          </p:cNvPr>
+          <p:cNvSpPr>
+            <a:spLocks noGrp="1"/>
+          </p:cNvSpPr>
+          <p:nvPr>
+            <p:ph type="sldNum" sz="quarter" idx="5"/>
+          </p:nvPr>
+        </p:nvSpPr>
+        <p:spPr/>
+        <p:txBody>
+          <a:bodyPr/>
+          <a:lstStyle/>
+          <a:p>
+            <a:fld id="{D16833E0-5E66-4D1D-89F5-BD860FDD8F71}" type="slidenum">
+              <a:rPr lang="en-MY" smtClean="0"/>
+              <a:t>7</a:t>
+            </a:fld>
+            <a:endParaRPr lang="en-MY"/>
+          </a:p>
+        </p:txBody>
+      </p:sp>
+    </p:spTree>
+    <p:extLst>
+      <p:ext uri="{BB962C8B-B14F-4D97-AF65-F5344CB8AC3E}">
+        <p14:creationId xmlns:p14="http://schemas.microsoft.com/office/powerpoint/2010/main" val="477282213"/>
+      </p:ext>
+    </p:extLst>
+  </p:cSld>
+  <p:clrMapOvr>
+    <a:masterClrMapping/>
+  </p:clrMapOvr>
+</p:notes>
+</file>
+
+<file path=ppt/notesSlides/notesSlide7.xml><?xml version="1.0" encoding="utf-8"?>
+<p:notes xmlns:a="http://schemas.openxmlformats.org/drawingml/2006/main" xmlns:r="http://schemas.openxmlformats.org/officeDocument/2006/relationships" xmlns:p="http://schemas.openxmlformats.org/presentationml/2006/main">
+  <p:cSld>
+    <p:spTree>
+      <p:nvGrpSpPr>
+        <p:cNvPr id="1" name="">
+          <a:extLst>
+            <a:ext uri="{FF2B5EF4-FFF2-40B4-BE49-F238E27FC236}">
               <a16:creationId xmlns:a16="http://schemas.microsoft.com/office/drawing/2014/main" id="{8AC23F3C-9F52-E969-49A3-3C9CC016D8D9}"/>
             </a:ext>
           </a:extLst>
@@ -2060,7 +2277,7 @@
           <a:p>
             <a:fld id="{D16833E0-5E66-4D1D-89F5-BD860FDD8F71}" type="slidenum">
               <a:rPr lang="en-MY" smtClean="0"/>
-              <a:t>7</a:t>
+              <a:t>8</a:t>
             </a:fld>
             <a:endParaRPr lang="en-MY"/>
           </a:p>
@@ -2079,7 +2296,7 @@
 </p:notes>
 </file>
 
-<file path=ppt/notesSlides/notesSlide7.xml><?xml version="1.0" encoding="utf-8"?>
+<file path=ppt/notesSlides/notesSlide8.xml><?xml version="1.0" encoding="utf-8"?>
 <p:notes xmlns:a="http://schemas.openxmlformats.org/drawingml/2006/main" xmlns:r="http://schemas.openxmlformats.org/officeDocument/2006/relationships" xmlns:p="http://schemas.openxmlformats.org/presentationml/2006/main">
   <p:cSld>
     <p:spTree>
@@ -2168,7 +2385,7 @@
           <a:p>
             <a:fld id="{D16833E0-5E66-4D1D-89F5-BD860FDD8F71}" type="slidenum">
               <a:rPr lang="en-MY" smtClean="0"/>
-              <a:t>8</a:t>
+              <a:t>9</a:t>
             </a:fld>
             <a:endParaRPr lang="en-MY"/>
           </a:p>
@@ -2187,7 +2404,7 @@
 </p:notes>
 </file>
 
-<file path=ppt/notesSlides/notesSlide8.xml><?xml version="1.0" encoding="utf-8"?>
+<file path=ppt/notesSlides/notesSlide9.xml><?xml version="1.0" encoding="utf-8"?>
 <p:notes xmlns:a="http://schemas.openxmlformats.org/drawingml/2006/main" xmlns:r="http://schemas.openxmlformats.org/officeDocument/2006/relationships" xmlns:p="http://schemas.openxmlformats.org/presentationml/2006/main">
   <p:cSld>
     <p:spTree>
@@ -2276,7 +2493,7 @@
           <a:p>
             <a:fld id="{D16833E0-5E66-4D1D-89F5-BD860FDD8F71}" type="slidenum">
               <a:rPr lang="en-MY" smtClean="0"/>
-              <a:t>9</a:t>
+              <a:t>10</a:t>
             </a:fld>
             <a:endParaRPr lang="en-MY"/>
           </a:p>
@@ -2286,114 +2503,6 @@
     <p:extLst>
       <p:ext uri="{BB962C8B-B14F-4D97-AF65-F5344CB8AC3E}">
         <p14:creationId xmlns:p14="http://schemas.microsoft.com/office/powerpoint/2010/main" val="2039971155"/>
-      </p:ext>
-    </p:extLst>
-  </p:cSld>
-  <p:clrMapOvr>
-    <a:masterClrMapping/>
-  </p:clrMapOvr>
-</p:notes>
-</file>
-
-<file path=ppt/notesSlides/notesSlide9.xml><?xml version="1.0" encoding="utf-8"?>
-<p:notes xmlns:a="http://schemas.openxmlformats.org/drawingml/2006/main" xmlns:r="http://schemas.openxmlformats.org/officeDocument/2006/relationships" xmlns:p="http://schemas.openxmlformats.org/presentationml/2006/main">
-  <p:cSld>
-    <p:spTree>
-      <p:nvGrpSpPr>
-        <p:cNvPr id="1" name="">
-          <a:extLst>
-            <a:ext uri="{FF2B5EF4-FFF2-40B4-BE49-F238E27FC236}">
-              <a16:creationId xmlns:a16="http://schemas.microsoft.com/office/drawing/2014/main" id="{CD65CC31-DDBD-A83E-77AD-73DD9EA7AADA}"/>
-            </a:ext>
-          </a:extLst>
-        </p:cNvPr>
-        <p:cNvGrpSpPr/>
-        <p:nvPr/>
-      </p:nvGrpSpPr>
-      <p:grpSpPr>
-        <a:xfrm>
-          <a:off x="0" y="0"/>
-          <a:ext cx="0" cy="0"/>
-          <a:chOff x="0" y="0"/>
-          <a:chExt cx="0" cy="0"/>
-        </a:xfrm>
-      </p:grpSpPr>
-      <p:sp>
-        <p:nvSpPr>
-          <p:cNvPr id="2" name="Slide Image Placeholder 1">
-            <a:extLst>
-              <a:ext uri="{FF2B5EF4-FFF2-40B4-BE49-F238E27FC236}">
-                <a16:creationId xmlns:a16="http://schemas.microsoft.com/office/drawing/2014/main" id="{75A6BE32-AD46-3994-D2B5-596BFA4482B9}"/>
-              </a:ext>
-            </a:extLst>
-          </p:cNvPr>
-          <p:cNvSpPr>
-            <a:spLocks noGrp="1" noRot="1" noChangeAspect="1"/>
-          </p:cNvSpPr>
-          <p:nvPr>
-            <p:ph type="sldImg"/>
-          </p:nvPr>
-        </p:nvSpPr>
-        <p:spPr/>
-      </p:sp>
-      <p:sp>
-        <p:nvSpPr>
-          <p:cNvPr id="3" name="Notes Placeholder 2">
-            <a:extLst>
-              <a:ext uri="{FF2B5EF4-FFF2-40B4-BE49-F238E27FC236}">
-                <a16:creationId xmlns:a16="http://schemas.microsoft.com/office/drawing/2014/main" id="{2DD8584B-F663-50AD-7BAD-29E261633728}"/>
-              </a:ext>
-            </a:extLst>
-          </p:cNvPr>
-          <p:cNvSpPr>
-            <a:spLocks noGrp="1"/>
-          </p:cNvSpPr>
-          <p:nvPr>
-            <p:ph type="body" idx="1"/>
-          </p:nvPr>
-        </p:nvSpPr>
-        <p:spPr/>
-        <p:txBody>
-          <a:bodyPr/>
-          <a:lstStyle/>
-          <a:p>
-            <a:endParaRPr lang="en-MY" dirty="0"/>
-          </a:p>
-        </p:txBody>
-      </p:sp>
-      <p:sp>
-        <p:nvSpPr>
-          <p:cNvPr id="4" name="Slide Number Placeholder 3">
-            <a:extLst>
-              <a:ext uri="{FF2B5EF4-FFF2-40B4-BE49-F238E27FC236}">
-                <a16:creationId xmlns:a16="http://schemas.microsoft.com/office/drawing/2014/main" id="{0A1087DB-E39A-687F-05EB-96BC857E8EC2}"/>
-              </a:ext>
-            </a:extLst>
-          </p:cNvPr>
-          <p:cNvSpPr>
-            <a:spLocks noGrp="1"/>
-          </p:cNvSpPr>
-          <p:nvPr>
-            <p:ph type="sldNum" sz="quarter" idx="5"/>
-          </p:nvPr>
-        </p:nvSpPr>
-        <p:spPr/>
-        <p:txBody>
-          <a:bodyPr/>
-          <a:lstStyle/>
-          <a:p>
-            <a:fld id="{D16833E0-5E66-4D1D-89F5-BD860FDD8F71}" type="slidenum">
-              <a:rPr lang="en-MY" smtClean="0"/>
-              <a:t>10</a:t>
-            </a:fld>
-            <a:endParaRPr lang="en-MY"/>
-          </a:p>
-        </p:txBody>
-      </p:sp>
-    </p:spTree>
-    <p:extLst>
-      <p:ext uri="{BB962C8B-B14F-4D97-AF65-F5344CB8AC3E}">
-        <p14:creationId xmlns:p14="http://schemas.microsoft.com/office/powerpoint/2010/main" val="1599132718"/>
       </p:ext>
     </p:extLst>
   </p:cSld>
@@ -2574,7 +2683,7 @@
           <a:p>
             <a:fld id="{1CD01395-AC05-405C-BAB9-E5D2B9FDBB40}" type="datetimeFigureOut">
               <a:rPr lang="en-MY" smtClean="0"/>
-              <a:t>6/5/2026</a:t>
+              <a:t>7/5/2026</a:t>
             </a:fld>
             <a:endParaRPr lang="en-MY"/>
           </a:p>
@@ -2889,7 +2998,7 @@
           <a:p>
             <a:fld id="{1CD01395-AC05-405C-BAB9-E5D2B9FDBB40}" type="datetimeFigureOut">
               <a:rPr lang="en-MY" smtClean="0"/>
-              <a:t>6/5/2026</a:t>
+              <a:t>7/5/2026</a:t>
             </a:fld>
             <a:endParaRPr lang="en-MY"/>
           </a:p>
@@ -3111,7 +3220,7 @@
           <a:p>
             <a:fld id="{1CD01395-AC05-405C-BAB9-E5D2B9FDBB40}" type="datetimeFigureOut">
               <a:rPr lang="en-MY" smtClean="0"/>
-              <a:t>6/5/2026</a:t>
+              <a:t>7/5/2026</a:t>
             </a:fld>
             <a:endParaRPr lang="en-MY"/>
           </a:p>
@@ -3402,7 +3511,7 @@
           <a:p>
             <a:fld id="{1CD01395-AC05-405C-BAB9-E5D2B9FDBB40}" type="datetimeFigureOut">
               <a:rPr lang="en-MY" smtClean="0"/>
-              <a:t>6/5/2026</a:t>
+              <a:t>7/5/2026</a:t>
             </a:fld>
             <a:endParaRPr lang="en-MY"/>
           </a:p>
@@ -3856,7 +3965,7 @@
           <a:p>
             <a:fld id="{1CD01395-AC05-405C-BAB9-E5D2B9FDBB40}" type="datetimeFigureOut">
               <a:rPr lang="en-MY" smtClean="0"/>
-              <a:t>6/5/2026</a:t>
+              <a:t>7/5/2026</a:t>
             </a:fld>
             <a:endParaRPr lang="en-MY"/>
           </a:p>
@@ -4432,7 +4541,7 @@
           <a:p>
             <a:fld id="{1CD01395-AC05-405C-BAB9-E5D2B9FDBB40}" type="datetimeFigureOut">
               <a:rPr lang="en-MY" smtClean="0"/>
-              <a:t>6/5/2026</a:t>
+              <a:t>7/5/2026</a:t>
             </a:fld>
             <a:endParaRPr lang="en-MY"/>
           </a:p>
@@ -5293,7 +5402,7 @@
           <a:p>
             <a:fld id="{1CD01395-AC05-405C-BAB9-E5D2B9FDBB40}" type="datetimeFigureOut">
               <a:rPr lang="en-MY" smtClean="0"/>
-              <a:t>6/5/2026</a:t>
+              <a:t>7/5/2026</a:t>
             </a:fld>
             <a:endParaRPr lang="en-MY"/>
           </a:p>
@@ -5498,7 +5607,7 @@
           <a:p>
             <a:fld id="{1CD01395-AC05-405C-BAB9-E5D2B9FDBB40}" type="datetimeFigureOut">
               <a:rPr lang="en-MY" smtClean="0"/>
-              <a:t>6/5/2026</a:t>
+              <a:t>7/5/2026</a:t>
             </a:fld>
             <a:endParaRPr lang="en-MY"/>
           </a:p>
@@ -5712,7 +5821,7 @@
           <a:p>
             <a:fld id="{1CD01395-AC05-405C-BAB9-E5D2B9FDBB40}" type="datetimeFigureOut">
               <a:rPr lang="en-MY" smtClean="0"/>
-              <a:t>6/5/2026</a:t>
+              <a:t>7/5/2026</a:t>
             </a:fld>
             <a:endParaRPr lang="en-MY"/>
           </a:p>
@@ -5917,7 +6026,7 @@
           <a:p>
             <a:fld id="{1CD01395-AC05-405C-BAB9-E5D2B9FDBB40}" type="datetimeFigureOut">
               <a:rPr lang="en-MY" smtClean="0"/>
-              <a:t>6/5/2026</a:t>
+              <a:t>7/5/2026</a:t>
             </a:fld>
             <a:endParaRPr lang="en-MY"/>
           </a:p>
@@ -6197,7 +6306,7 @@
           <a:p>
             <a:fld id="{1CD01395-AC05-405C-BAB9-E5D2B9FDBB40}" type="datetimeFigureOut">
               <a:rPr lang="en-MY" smtClean="0"/>
-              <a:t>6/5/2026</a:t>
+              <a:t>7/5/2026</a:t>
             </a:fld>
             <a:endParaRPr lang="en-MY"/>
           </a:p>
@@ -6464,7 +6573,7 @@
           <a:p>
             <a:fld id="{1CD01395-AC05-405C-BAB9-E5D2B9FDBB40}" type="datetimeFigureOut">
               <a:rPr lang="en-MY" smtClean="0"/>
-              <a:t>6/5/2026</a:t>
+              <a:t>7/5/2026</a:t>
             </a:fld>
             <a:endParaRPr lang="en-MY"/>
           </a:p>
@@ -6879,7 +6988,7 @@
           <a:p>
             <a:fld id="{1CD01395-AC05-405C-BAB9-E5D2B9FDBB40}" type="datetimeFigureOut">
               <a:rPr lang="en-MY" smtClean="0"/>
-              <a:t>6/5/2026</a:t>
+              <a:t>7/5/2026</a:t>
             </a:fld>
             <a:endParaRPr lang="en-MY"/>
           </a:p>
@@ -7027,7 +7136,7 @@
           <a:p>
             <a:fld id="{1CD01395-AC05-405C-BAB9-E5D2B9FDBB40}" type="datetimeFigureOut">
               <a:rPr lang="en-MY" smtClean="0"/>
-              <a:t>6/5/2026</a:t>
+              <a:t>7/5/2026</a:t>
             </a:fld>
             <a:endParaRPr lang="en-MY"/>
           </a:p>
@@ -7152,7 +7261,7 @@
           <a:p>
             <a:fld id="{1CD01395-AC05-405C-BAB9-E5D2B9FDBB40}" type="datetimeFigureOut">
               <a:rPr lang="en-MY" smtClean="0"/>
-              <a:t>6/5/2026</a:t>
+              <a:t>7/5/2026</a:t>
             </a:fld>
             <a:endParaRPr lang="en-MY"/>
           </a:p>
@@ -7431,7 +7540,7 @@
           <a:p>
             <a:fld id="{1CD01395-AC05-405C-BAB9-E5D2B9FDBB40}" type="datetimeFigureOut">
               <a:rPr lang="en-MY" smtClean="0"/>
-              <a:t>6/5/2026</a:t>
+              <a:t>7/5/2026</a:t>
             </a:fld>
             <a:endParaRPr lang="en-MY"/>
           </a:p>
@@ -7746,7 +7855,7 @@
           <a:p>
             <a:fld id="{1CD01395-AC05-405C-BAB9-E5D2B9FDBB40}" type="datetimeFigureOut">
               <a:rPr lang="en-MY" smtClean="0"/>
-              <a:t>6/5/2026</a:t>
+              <a:t>7/5/2026</a:t>
             </a:fld>
             <a:endParaRPr lang="en-MY"/>
           </a:p>
@@ -7999,7 +8108,7 @@
           <a:p>
             <a:fld id="{1CD01395-AC05-405C-BAB9-E5D2B9FDBB40}" type="datetimeFigureOut">
               <a:rPr lang="en-MY" smtClean="0"/>
-              <a:t>6/5/2026</a:t>
+              <a:t>7/5/2026</a:t>
             </a:fld>
             <a:endParaRPr lang="en-MY"/>
           </a:p>
@@ -8536,6 +8645,110 @@
         <p:cNvPr id="1" name="">
           <a:extLst>
             <a:ext uri="{FF2B5EF4-FFF2-40B4-BE49-F238E27FC236}">
+              <a16:creationId xmlns:a16="http://schemas.microsoft.com/office/drawing/2014/main" id="{3FBC84F0-4790-2E5C-BD77-A69CA39F653E}"/>
+            </a:ext>
+          </a:extLst>
+        </p:cNvPr>
+        <p:cNvGrpSpPr/>
+        <p:nvPr/>
+      </p:nvGrpSpPr>
+      <p:grpSpPr>
+        <a:xfrm>
+          <a:off x="0" y="0"/>
+          <a:ext cx="0" cy="0"/>
+          <a:chOff x="0" y="0"/>
+          <a:chExt cx="0" cy="0"/>
+        </a:xfrm>
+      </p:grpSpPr>
+      <p:pic>
+        <p:nvPicPr>
+          <p:cNvPr id="3" name="Picture 2">
+            <a:extLst>
+              <a:ext uri="{FF2B5EF4-FFF2-40B4-BE49-F238E27FC236}">
+                <a16:creationId xmlns:a16="http://schemas.microsoft.com/office/drawing/2014/main" id="{765F6181-9D1F-12D2-690A-B5E1843D8AAA}"/>
+              </a:ext>
+            </a:extLst>
+          </p:cNvPr>
+          <p:cNvPicPr>
+            <a:picLocks noChangeAspect="1"/>
+          </p:cNvPicPr>
+          <p:nvPr/>
+        </p:nvPicPr>
+        <p:blipFill>
+          <a:blip r:embed="rId3"/>
+          <a:stretch>
+            <a:fillRect/>
+          </a:stretch>
+        </p:blipFill>
+        <p:spPr>
+          <a:xfrm>
+            <a:off x="6505599" y="427712"/>
+            <a:ext cx="5106113" cy="4887007"/>
+          </a:xfrm>
+          <a:prstGeom prst="rect">
+            <a:avLst/>
+          </a:prstGeom>
+        </p:spPr>
+      </p:pic>
+      <p:pic>
+        <p:nvPicPr>
+          <p:cNvPr id="5" name="Picture 4">
+            <a:extLst>
+              <a:ext uri="{FF2B5EF4-FFF2-40B4-BE49-F238E27FC236}">
+                <a16:creationId xmlns:a16="http://schemas.microsoft.com/office/drawing/2014/main" id="{6A5C0805-4E2A-35B6-B6D6-E50B70D35153}"/>
+              </a:ext>
+            </a:extLst>
+          </p:cNvPr>
+          <p:cNvPicPr>
+            <a:picLocks noChangeAspect="1"/>
+          </p:cNvPicPr>
+          <p:nvPr/>
+        </p:nvPicPr>
+        <p:blipFill>
+          <a:blip r:embed="rId4"/>
+          <a:stretch>
+            <a:fillRect/>
+          </a:stretch>
+        </p:blipFill>
+        <p:spPr>
+          <a:xfrm>
+            <a:off x="856870" y="427712"/>
+            <a:ext cx="5449060" cy="5210902"/>
+          </a:xfrm>
+          <a:prstGeom prst="rect">
+            <a:avLst/>
+          </a:prstGeom>
+        </p:spPr>
+      </p:pic>
+    </p:spTree>
+    <p:extLst>
+      <p:ext uri="{BB962C8B-B14F-4D97-AF65-F5344CB8AC3E}">
+        <p14:creationId xmlns:p14="http://schemas.microsoft.com/office/powerpoint/2010/main" val="1025226808"/>
+      </p:ext>
+    </p:extLst>
+  </p:cSld>
+  <p:clrMapOvr>
+    <a:masterClrMapping/>
+  </p:clrMapOvr>
+</p:sld>
+</file>
+
+<file path=ppt/slides/slide11.xml><?xml version="1.0" encoding="utf-8"?>
+<p:sld xmlns:a="http://schemas.openxmlformats.org/drawingml/2006/main" xmlns:r="http://schemas.openxmlformats.org/officeDocument/2006/relationships" xmlns:p="http://schemas.openxmlformats.org/presentationml/2006/main" showMasterSp="0">
+  <p:cSld>
+    <p:bg>
+      <p:bgPr>
+        <a:solidFill>
+          <a:srgbClr val="CDF6F9"/>
+        </a:solidFill>
+        <a:effectLst/>
+      </p:bgPr>
+    </p:bg>
+    <p:spTree>
+      <p:nvGrpSpPr>
+        <p:cNvPr id="1" name="">
+          <a:extLst>
+            <a:ext uri="{FF2B5EF4-FFF2-40B4-BE49-F238E27FC236}">
               <a16:creationId xmlns:a16="http://schemas.microsoft.com/office/drawing/2014/main" id="{58E68DF9-9D3D-F010-53FB-6A72464ACF27}"/>
             </a:ext>
           </a:extLst>
@@ -8625,7 +8838,7 @@
 </p:sld>
 </file>
 
-<file path=ppt/slides/slide11.xml><?xml version="1.0" encoding="utf-8"?>
+<file path=ppt/slides/slide12.xml><?xml version="1.0" encoding="utf-8"?>
 <p:sld xmlns:a="http://schemas.openxmlformats.org/drawingml/2006/main" xmlns:r="http://schemas.openxmlformats.org/officeDocument/2006/relationships" xmlns:p="http://schemas.openxmlformats.org/presentationml/2006/main" showMasterSp="0">
   <p:cSld>
     <p:bg>
@@ -10282,7 +10495,7 @@
 </p:sld>
 </file>
 
-<file path=ppt/slides/slide12.xml><?xml version="1.0" encoding="utf-8"?>
+<file path=ppt/slides/slide13.xml><?xml version="1.0" encoding="utf-8"?>
 <p:sld xmlns:a="http://schemas.openxmlformats.org/drawingml/2006/main" xmlns:r="http://schemas.openxmlformats.org/officeDocument/2006/relationships" xmlns:p="http://schemas.openxmlformats.org/presentationml/2006/main" showMasterSp="0">
   <p:cSld>
     <p:bg>
@@ -11677,7 +11890,7 @@
 </p:sld>
 </file>
 
-<file path=ppt/slides/slide13.xml><?xml version="1.0" encoding="utf-8"?>
+<file path=ppt/slides/slide14.xml><?xml version="1.0" encoding="utf-8"?>
 <p:sld xmlns:a="http://schemas.openxmlformats.org/drawingml/2006/main" xmlns:r="http://schemas.openxmlformats.org/officeDocument/2006/relationships" xmlns:p="http://schemas.openxmlformats.org/presentationml/2006/main" showMasterSp="0">
   <p:cSld>
     <p:bg>
@@ -11772,7 +11985,7 @@
 </p:sld>
 </file>
 
-<file path=ppt/slides/slide14.xml><?xml version="1.0" encoding="utf-8"?>
+<file path=ppt/slides/slide15.xml><?xml version="1.0" encoding="utf-8"?>
 <p:sld xmlns:a="http://schemas.openxmlformats.org/drawingml/2006/main" xmlns:r="http://schemas.openxmlformats.org/officeDocument/2006/relationships" xmlns:p="http://schemas.openxmlformats.org/presentationml/2006/main" showMasterSp="0">
   <p:cSld>
     <p:bg>
@@ -12388,7 +12601,7 @@
 </p:sld>
 </file>
 
-<file path=ppt/slides/slide15.xml><?xml version="1.0" encoding="utf-8"?>
+<file path=ppt/slides/slide16.xml><?xml version="1.0" encoding="utf-8"?>
 <p:sld xmlns:a="http://schemas.openxmlformats.org/drawingml/2006/main" xmlns:r="http://schemas.openxmlformats.org/officeDocument/2006/relationships" xmlns:p="http://schemas.openxmlformats.org/presentationml/2006/main" showMasterSp="0">
   <p:cSld>
     <p:bg>
@@ -12483,7 +12696,7 @@
 </p:sld>
 </file>
 
-<file path=ppt/slides/slide16.xml><?xml version="1.0" encoding="utf-8"?>
+<file path=ppt/slides/slide17.xml><?xml version="1.0" encoding="utf-8"?>
 <p:sld xmlns:a="http://schemas.openxmlformats.org/drawingml/2006/main" xmlns:r="http://schemas.openxmlformats.org/officeDocument/2006/relationships" xmlns:p="http://schemas.openxmlformats.org/presentationml/2006/main" showMasterSp="0">
   <p:cSld>
     <p:bg>
@@ -12722,7 +12935,7 @@
 </p:sld>
 </file>
 
-<file path=ppt/slides/slide17.xml><?xml version="1.0" encoding="utf-8"?>
+<file path=ppt/slides/slide18.xml><?xml version="1.0" encoding="utf-8"?>
 <p:sld xmlns:a="http://schemas.openxmlformats.org/drawingml/2006/main" xmlns:r="http://schemas.openxmlformats.org/officeDocument/2006/relationships" xmlns:p="http://schemas.openxmlformats.org/presentationml/2006/main" showMasterSp="0">
   <p:cSld>
     <p:bg>
@@ -12952,7 +13165,7 @@
 </p:sld>
 </file>
 
-<file path=ppt/slides/slide18.xml><?xml version="1.0" encoding="utf-8"?>
+<file path=ppt/slides/slide19.xml><?xml version="1.0" encoding="utf-8"?>
 <p:sld xmlns:a="http://schemas.openxmlformats.org/drawingml/2006/main" xmlns:r="http://schemas.openxmlformats.org/officeDocument/2006/relationships" xmlns:p="http://schemas.openxmlformats.org/presentationml/2006/main" showMasterSp="0">
   <p:cSld>
     <p:bg>
@@ -13130,237 +13343,6 @@
     <p:extLst>
       <p:ext uri="{BB962C8B-B14F-4D97-AF65-F5344CB8AC3E}">
         <p14:creationId xmlns:p14="http://schemas.microsoft.com/office/powerpoint/2010/main" val="3597209293"/>
-      </p:ext>
-    </p:extLst>
-  </p:cSld>
-  <p:clrMapOvr>
-    <a:masterClrMapping/>
-  </p:clrMapOvr>
-</p:sld>
-</file>
-
-<file path=ppt/slides/slide19.xml><?xml version="1.0" encoding="utf-8"?>
-<p:sld xmlns:a="http://schemas.openxmlformats.org/drawingml/2006/main" xmlns:r="http://schemas.openxmlformats.org/officeDocument/2006/relationships" xmlns:p="http://schemas.openxmlformats.org/presentationml/2006/main" showMasterSp="0">
-  <p:cSld>
-    <p:bg>
-      <p:bgPr>
-        <a:solidFill>
-          <a:srgbClr val="CDF6F9"/>
-        </a:solidFill>
-        <a:effectLst/>
-      </p:bgPr>
-    </p:bg>
-    <p:spTree>
-      <p:nvGrpSpPr>
-        <p:cNvPr id="1" name="">
-          <a:extLst>
-            <a:ext uri="{FF2B5EF4-FFF2-40B4-BE49-F238E27FC236}">
-              <a16:creationId xmlns:a16="http://schemas.microsoft.com/office/drawing/2014/main" id="{496294E8-DB96-89DD-76FD-F0FEDF6D616B}"/>
-            </a:ext>
-          </a:extLst>
-        </p:cNvPr>
-        <p:cNvGrpSpPr/>
-        <p:nvPr/>
-      </p:nvGrpSpPr>
-      <p:grpSpPr>
-        <a:xfrm>
-          <a:off x="0" y="0"/>
-          <a:ext cx="0" cy="0"/>
-          <a:chOff x="0" y="0"/>
-          <a:chExt cx="0" cy="0"/>
-        </a:xfrm>
-      </p:grpSpPr>
-      <p:sp>
-        <p:nvSpPr>
-          <p:cNvPr id="5" name="Rectangle 4">
-            <a:extLst>
-              <a:ext uri="{FF2B5EF4-FFF2-40B4-BE49-F238E27FC236}">
-                <a16:creationId xmlns:a16="http://schemas.microsoft.com/office/drawing/2014/main" id="{65CA863E-898B-B444-42D6-372454A7A07A}"/>
-              </a:ext>
-            </a:extLst>
-          </p:cNvPr>
-          <p:cNvSpPr/>
-          <p:nvPr/>
-        </p:nvSpPr>
-        <p:spPr>
-          <a:xfrm>
-            <a:off x="3861306" y="134065"/>
-            <a:ext cx="5235070" cy="389810"/>
-          </a:xfrm>
-          <a:prstGeom prst="rect">
-            <a:avLst/>
-          </a:prstGeom>
-          <a:noFill/>
-          <a:ln>
-            <a:noFill/>
-          </a:ln>
-        </p:spPr>
-        <p:style>
-          <a:lnRef idx="2">
-            <a:schemeClr val="accent6"/>
-          </a:lnRef>
-          <a:fillRef idx="1">
-            <a:schemeClr val="lt1"/>
-          </a:fillRef>
-          <a:effectRef idx="0">
-            <a:schemeClr val="accent6"/>
-          </a:effectRef>
-          <a:fontRef idx="minor">
-            <a:schemeClr val="dk1"/>
-          </a:fontRef>
-        </p:style>
-        <p:txBody>
-          <a:bodyPr rtlCol="0" anchor="ctr"/>
-          <a:lstStyle/>
-          <a:p>
-            <a:pPr algn="ctr"/>
-            <a:r>
-              <a:rPr lang="en-MY" sz="1400" dirty="0"/>
-              <a:t>CUSTOMER : UGS  </a:t>
-            </a:r>
-            <a:r>
-              <a:rPr lang="en-US" sz="1400" dirty="0"/>
-              <a:t>P</a:t>
-            </a:r>
-            <a:r>
-              <a:rPr lang="en-MY" sz="1400" dirty="0"/>
-              <a:t>ROJECT: A1887 TOTAL DEVICE : 286</a:t>
-            </a:r>
-          </a:p>
-        </p:txBody>
-      </p:sp>
-      <p:sp>
-        <p:nvSpPr>
-          <p:cNvPr id="10" name="TextBox 9">
-            <a:extLst>
-              <a:ext uri="{FF2B5EF4-FFF2-40B4-BE49-F238E27FC236}">
-                <a16:creationId xmlns:a16="http://schemas.microsoft.com/office/drawing/2014/main" id="{E6238E74-41BE-EAF8-7443-9CB7F70C1DEC}"/>
-              </a:ext>
-            </a:extLst>
-          </p:cNvPr>
-          <p:cNvSpPr txBox="1"/>
-          <p:nvPr/>
-        </p:nvSpPr>
-        <p:spPr>
-          <a:xfrm>
-            <a:off x="95250" y="6593130"/>
-            <a:ext cx="7924800" cy="261610"/>
-          </a:xfrm>
-          <a:prstGeom prst="rect">
-            <a:avLst/>
-          </a:prstGeom>
-          <a:noFill/>
-        </p:spPr>
-        <p:txBody>
-          <a:bodyPr wrap="square">
-            <a:spAutoFit/>
-          </a:bodyPr>
-          <a:lstStyle/>
-          <a:p>
-            <a:r>
-              <a:rPr lang="en-MY" sz="1050" dirty="0" err="1"/>
-              <a:t>Filepath</a:t>
-            </a:r>
-            <a:r>
-              <a:rPr lang="en-MY" sz="1050" dirty="0"/>
-              <a:t>  : "C:\Users\sitisyaziyah\Documents\Device_Identifier\Dummy data\UGS - structured data.xlsx“ (sheet = A1887-S2)</a:t>
-            </a:r>
-          </a:p>
-        </p:txBody>
-      </p:sp>
-      <p:pic>
-        <p:nvPicPr>
-          <p:cNvPr id="3" name="Picture 2">
-            <a:extLst>
-              <a:ext uri="{FF2B5EF4-FFF2-40B4-BE49-F238E27FC236}">
-                <a16:creationId xmlns:a16="http://schemas.microsoft.com/office/drawing/2014/main" id="{26DED758-7E45-8B88-A1CE-96FED269D5C0}"/>
-              </a:ext>
-            </a:extLst>
-          </p:cNvPr>
-          <p:cNvPicPr>
-            <a:picLocks noChangeAspect="1"/>
-          </p:cNvPicPr>
-          <p:nvPr/>
-        </p:nvPicPr>
-        <p:blipFill>
-          <a:blip r:embed="rId3"/>
-          <a:stretch>
-            <a:fillRect/>
-          </a:stretch>
-        </p:blipFill>
-        <p:spPr>
-          <a:xfrm>
-            <a:off x="2081358" y="500715"/>
-            <a:ext cx="8794965" cy="6092415"/>
-          </a:xfrm>
-          <a:prstGeom prst="rect">
-            <a:avLst/>
-          </a:prstGeom>
-        </p:spPr>
-      </p:pic>
-      <p:sp>
-        <p:nvSpPr>
-          <p:cNvPr id="2" name="TextBox 1">
-            <a:extLst>
-              <a:ext uri="{FF2B5EF4-FFF2-40B4-BE49-F238E27FC236}">
-                <a16:creationId xmlns:a16="http://schemas.microsoft.com/office/drawing/2014/main" id="{CF6F83BE-392E-BF69-95E6-E186F278EF24}"/>
-              </a:ext>
-            </a:extLst>
-          </p:cNvPr>
-          <p:cNvSpPr txBox="1"/>
-          <p:nvPr/>
-        </p:nvSpPr>
-        <p:spPr>
-          <a:xfrm>
-            <a:off x="261702" y="500715"/>
-            <a:ext cx="1819656" cy="1200329"/>
-          </a:xfrm>
-          <a:prstGeom prst="rect">
-            <a:avLst/>
-          </a:prstGeom>
-          <a:noFill/>
-        </p:spPr>
-        <p:txBody>
-          <a:bodyPr wrap="square" rtlCol="0">
-            <a:spAutoFit/>
-          </a:bodyPr>
-          <a:lstStyle/>
-          <a:p>
-            <a:r>
-              <a:rPr lang="en-MY" dirty="0">
-                <a:solidFill>
-                  <a:srgbClr val="FF0000"/>
-                </a:solidFill>
-              </a:rPr>
-              <a:t>Note 16/4/2026</a:t>
-            </a:r>
-          </a:p>
-          <a:p>
-            <a:r>
-              <a:rPr lang="en-MY" dirty="0">
-                <a:solidFill>
-                  <a:srgbClr val="FF0000"/>
-                </a:solidFill>
-              </a:rPr>
-              <a:t>DROPOUT OILTEK_A1827</a:t>
-            </a:r>
-          </a:p>
-          <a:p>
-            <a:r>
-              <a:rPr lang="en-MY" dirty="0">
-                <a:solidFill>
-                  <a:srgbClr val="FF0000"/>
-                </a:solidFill>
-              </a:rPr>
-              <a:t>UGS_A1887</a:t>
-            </a:r>
-          </a:p>
-        </p:txBody>
-      </p:sp>
-    </p:spTree>
-    <p:extLst>
-      <p:ext uri="{BB962C8B-B14F-4D97-AF65-F5344CB8AC3E}">
-        <p14:creationId xmlns:p14="http://schemas.microsoft.com/office/powerpoint/2010/main" val="1691097330"/>
       </p:ext>
     </p:extLst>
   </p:cSld>
@@ -15017,6 +14999,237 @@
     <p:extLst>
       <p:ext uri="{BB962C8B-B14F-4D97-AF65-F5344CB8AC3E}">
         <p14:creationId xmlns:p14="http://schemas.microsoft.com/office/powerpoint/2010/main" val="2766375949"/>
+      </p:ext>
+    </p:extLst>
+  </p:cSld>
+  <p:clrMapOvr>
+    <a:masterClrMapping/>
+  </p:clrMapOvr>
+</p:sld>
+</file>
+
+<file path=ppt/slides/slide20.xml><?xml version="1.0" encoding="utf-8"?>
+<p:sld xmlns:a="http://schemas.openxmlformats.org/drawingml/2006/main" xmlns:r="http://schemas.openxmlformats.org/officeDocument/2006/relationships" xmlns:p="http://schemas.openxmlformats.org/presentationml/2006/main" showMasterSp="0">
+  <p:cSld>
+    <p:bg>
+      <p:bgPr>
+        <a:solidFill>
+          <a:srgbClr val="CDF6F9"/>
+        </a:solidFill>
+        <a:effectLst/>
+      </p:bgPr>
+    </p:bg>
+    <p:spTree>
+      <p:nvGrpSpPr>
+        <p:cNvPr id="1" name="">
+          <a:extLst>
+            <a:ext uri="{FF2B5EF4-FFF2-40B4-BE49-F238E27FC236}">
+              <a16:creationId xmlns:a16="http://schemas.microsoft.com/office/drawing/2014/main" id="{496294E8-DB96-89DD-76FD-F0FEDF6D616B}"/>
+            </a:ext>
+          </a:extLst>
+        </p:cNvPr>
+        <p:cNvGrpSpPr/>
+        <p:nvPr/>
+      </p:nvGrpSpPr>
+      <p:grpSpPr>
+        <a:xfrm>
+          <a:off x="0" y="0"/>
+          <a:ext cx="0" cy="0"/>
+          <a:chOff x="0" y="0"/>
+          <a:chExt cx="0" cy="0"/>
+        </a:xfrm>
+      </p:grpSpPr>
+      <p:sp>
+        <p:nvSpPr>
+          <p:cNvPr id="5" name="Rectangle 4">
+            <a:extLst>
+              <a:ext uri="{FF2B5EF4-FFF2-40B4-BE49-F238E27FC236}">
+                <a16:creationId xmlns:a16="http://schemas.microsoft.com/office/drawing/2014/main" id="{65CA863E-898B-B444-42D6-372454A7A07A}"/>
+              </a:ext>
+            </a:extLst>
+          </p:cNvPr>
+          <p:cNvSpPr/>
+          <p:nvPr/>
+        </p:nvSpPr>
+        <p:spPr>
+          <a:xfrm>
+            <a:off x="3861306" y="134065"/>
+            <a:ext cx="5235070" cy="389810"/>
+          </a:xfrm>
+          <a:prstGeom prst="rect">
+            <a:avLst/>
+          </a:prstGeom>
+          <a:noFill/>
+          <a:ln>
+            <a:noFill/>
+          </a:ln>
+        </p:spPr>
+        <p:style>
+          <a:lnRef idx="2">
+            <a:schemeClr val="accent6"/>
+          </a:lnRef>
+          <a:fillRef idx="1">
+            <a:schemeClr val="lt1"/>
+          </a:fillRef>
+          <a:effectRef idx="0">
+            <a:schemeClr val="accent6"/>
+          </a:effectRef>
+          <a:fontRef idx="minor">
+            <a:schemeClr val="dk1"/>
+          </a:fontRef>
+        </p:style>
+        <p:txBody>
+          <a:bodyPr rtlCol="0" anchor="ctr"/>
+          <a:lstStyle/>
+          <a:p>
+            <a:pPr algn="ctr"/>
+            <a:r>
+              <a:rPr lang="en-MY" sz="1400" dirty="0"/>
+              <a:t>CUSTOMER : UGS  </a:t>
+            </a:r>
+            <a:r>
+              <a:rPr lang="en-US" sz="1400" dirty="0"/>
+              <a:t>P</a:t>
+            </a:r>
+            <a:r>
+              <a:rPr lang="en-MY" sz="1400" dirty="0"/>
+              <a:t>ROJECT: A1887 TOTAL DEVICE : 286</a:t>
+            </a:r>
+          </a:p>
+        </p:txBody>
+      </p:sp>
+      <p:sp>
+        <p:nvSpPr>
+          <p:cNvPr id="10" name="TextBox 9">
+            <a:extLst>
+              <a:ext uri="{FF2B5EF4-FFF2-40B4-BE49-F238E27FC236}">
+                <a16:creationId xmlns:a16="http://schemas.microsoft.com/office/drawing/2014/main" id="{E6238E74-41BE-EAF8-7443-9CB7F70C1DEC}"/>
+              </a:ext>
+            </a:extLst>
+          </p:cNvPr>
+          <p:cNvSpPr txBox="1"/>
+          <p:nvPr/>
+        </p:nvSpPr>
+        <p:spPr>
+          <a:xfrm>
+            <a:off x="95250" y="6593130"/>
+            <a:ext cx="7924800" cy="261610"/>
+          </a:xfrm>
+          <a:prstGeom prst="rect">
+            <a:avLst/>
+          </a:prstGeom>
+          <a:noFill/>
+        </p:spPr>
+        <p:txBody>
+          <a:bodyPr wrap="square">
+            <a:spAutoFit/>
+          </a:bodyPr>
+          <a:lstStyle/>
+          <a:p>
+            <a:r>
+              <a:rPr lang="en-MY" sz="1050" dirty="0" err="1"/>
+              <a:t>Filepath</a:t>
+            </a:r>
+            <a:r>
+              <a:rPr lang="en-MY" sz="1050" dirty="0"/>
+              <a:t>  : "C:\Users\sitisyaziyah\Documents\Device_Identifier\Dummy data\UGS - structured data.xlsx“ (sheet = A1887-S2)</a:t>
+            </a:r>
+          </a:p>
+        </p:txBody>
+      </p:sp>
+      <p:pic>
+        <p:nvPicPr>
+          <p:cNvPr id="3" name="Picture 2">
+            <a:extLst>
+              <a:ext uri="{FF2B5EF4-FFF2-40B4-BE49-F238E27FC236}">
+                <a16:creationId xmlns:a16="http://schemas.microsoft.com/office/drawing/2014/main" id="{26DED758-7E45-8B88-A1CE-96FED269D5C0}"/>
+              </a:ext>
+            </a:extLst>
+          </p:cNvPr>
+          <p:cNvPicPr>
+            <a:picLocks noChangeAspect="1"/>
+          </p:cNvPicPr>
+          <p:nvPr/>
+        </p:nvPicPr>
+        <p:blipFill>
+          <a:blip r:embed="rId3"/>
+          <a:stretch>
+            <a:fillRect/>
+          </a:stretch>
+        </p:blipFill>
+        <p:spPr>
+          <a:xfrm>
+            <a:off x="2081358" y="500715"/>
+            <a:ext cx="8794965" cy="6092415"/>
+          </a:xfrm>
+          <a:prstGeom prst="rect">
+            <a:avLst/>
+          </a:prstGeom>
+        </p:spPr>
+      </p:pic>
+      <p:sp>
+        <p:nvSpPr>
+          <p:cNvPr id="2" name="TextBox 1">
+            <a:extLst>
+              <a:ext uri="{FF2B5EF4-FFF2-40B4-BE49-F238E27FC236}">
+                <a16:creationId xmlns:a16="http://schemas.microsoft.com/office/drawing/2014/main" id="{CF6F83BE-392E-BF69-95E6-E186F278EF24}"/>
+              </a:ext>
+            </a:extLst>
+          </p:cNvPr>
+          <p:cNvSpPr txBox="1"/>
+          <p:nvPr/>
+        </p:nvSpPr>
+        <p:spPr>
+          <a:xfrm>
+            <a:off x="261702" y="500715"/>
+            <a:ext cx="1819656" cy="1200329"/>
+          </a:xfrm>
+          <a:prstGeom prst="rect">
+            <a:avLst/>
+          </a:prstGeom>
+          <a:noFill/>
+        </p:spPr>
+        <p:txBody>
+          <a:bodyPr wrap="square" rtlCol="0">
+            <a:spAutoFit/>
+          </a:bodyPr>
+          <a:lstStyle/>
+          <a:p>
+            <a:r>
+              <a:rPr lang="en-MY" dirty="0">
+                <a:solidFill>
+                  <a:srgbClr val="FF0000"/>
+                </a:solidFill>
+              </a:rPr>
+              <a:t>Note 16/4/2026</a:t>
+            </a:r>
+          </a:p>
+          <a:p>
+            <a:r>
+              <a:rPr lang="en-MY" dirty="0">
+                <a:solidFill>
+                  <a:srgbClr val="FF0000"/>
+                </a:solidFill>
+              </a:rPr>
+              <a:t>DROPOUT OILTEK_A1827</a:t>
+            </a:r>
+          </a:p>
+          <a:p>
+            <a:r>
+              <a:rPr lang="en-MY" dirty="0">
+                <a:solidFill>
+                  <a:srgbClr val="FF0000"/>
+                </a:solidFill>
+              </a:rPr>
+              <a:t>UGS_A1887</a:t>
+            </a:r>
+          </a:p>
+        </p:txBody>
+      </p:sp>
+    </p:spTree>
+    <p:extLst>
+      <p:ext uri="{BB962C8B-B14F-4D97-AF65-F5344CB8AC3E}">
+        <p14:creationId xmlns:p14="http://schemas.microsoft.com/office/powerpoint/2010/main" val="1691097330"/>
       </p:ext>
     </p:extLst>
   </p:cSld>
@@ -15363,6 +15576,80 @@
         <p:cNvPr id="1" name="">
           <a:extLst>
             <a:ext uri="{FF2B5EF4-FFF2-40B4-BE49-F238E27FC236}">
+              <a16:creationId xmlns:a16="http://schemas.microsoft.com/office/drawing/2014/main" id="{696F804E-D4EC-500A-6070-EB128E4F073E}"/>
+            </a:ext>
+          </a:extLst>
+        </p:cNvPr>
+        <p:cNvGrpSpPr/>
+        <p:nvPr/>
+      </p:nvGrpSpPr>
+      <p:grpSpPr>
+        <a:xfrm>
+          <a:off x="0" y="0"/>
+          <a:ext cx="0" cy="0"/>
+          <a:chOff x="0" y="0"/>
+          <a:chExt cx="0" cy="0"/>
+        </a:xfrm>
+      </p:grpSpPr>
+      <p:pic>
+        <p:nvPicPr>
+          <p:cNvPr id="4" name="Picture 3">
+            <a:extLst>
+              <a:ext uri="{FF2B5EF4-FFF2-40B4-BE49-F238E27FC236}">
+                <a16:creationId xmlns:a16="http://schemas.microsoft.com/office/drawing/2014/main" id="{1705D8E4-4CF0-C70E-4707-E5D08580DE9F}"/>
+              </a:ext>
+            </a:extLst>
+          </p:cNvPr>
+          <p:cNvPicPr>
+            <a:picLocks noChangeAspect="1"/>
+          </p:cNvPicPr>
+          <p:nvPr/>
+        </p:nvPicPr>
+        <p:blipFill>
+          <a:blip r:embed="rId3"/>
+          <a:stretch>
+            <a:fillRect/>
+          </a:stretch>
+        </p:blipFill>
+        <p:spPr>
+          <a:xfrm>
+            <a:off x="189675" y="2528762"/>
+            <a:ext cx="11812649" cy="1800476"/>
+          </a:xfrm>
+          <a:prstGeom prst="rect">
+            <a:avLst/>
+          </a:prstGeom>
+        </p:spPr>
+      </p:pic>
+    </p:spTree>
+    <p:extLst>
+      <p:ext uri="{BB962C8B-B14F-4D97-AF65-F5344CB8AC3E}">
+        <p14:creationId xmlns:p14="http://schemas.microsoft.com/office/powerpoint/2010/main" val="3409841615"/>
+      </p:ext>
+    </p:extLst>
+  </p:cSld>
+  <p:clrMapOvr>
+    <a:masterClrMapping/>
+  </p:clrMapOvr>
+</p:sld>
+</file>
+
+<file path=ppt/slides/slide8.xml><?xml version="1.0" encoding="utf-8"?>
+<p:sld xmlns:a="http://schemas.openxmlformats.org/drawingml/2006/main" xmlns:r="http://schemas.openxmlformats.org/officeDocument/2006/relationships" xmlns:p="http://schemas.openxmlformats.org/presentationml/2006/main" showMasterSp="0">
+  <p:cSld>
+    <p:bg>
+      <p:bgPr>
+        <a:solidFill>
+          <a:srgbClr val="CDF6F9"/>
+        </a:solidFill>
+        <a:effectLst/>
+      </p:bgPr>
+    </p:bg>
+    <p:spTree>
+      <p:nvGrpSpPr>
+        <p:cNvPr id="1" name="">
+          <a:extLst>
+            <a:ext uri="{FF2B5EF4-FFF2-40B4-BE49-F238E27FC236}">
               <a16:creationId xmlns:a16="http://schemas.microsoft.com/office/drawing/2014/main" id="{5700AD06-AC27-890A-9253-1A1180DFE688}"/>
             </a:ext>
           </a:extLst>
@@ -15421,7 +15708,7 @@
 </p:sld>
 </file>
 
-<file path=ppt/slides/slide8.xml><?xml version="1.0" encoding="utf-8"?>
+<file path=ppt/slides/slide9.xml><?xml version="1.0" encoding="utf-8"?>
 <p:sld xmlns:a="http://schemas.openxmlformats.org/drawingml/2006/main" xmlns:r="http://schemas.openxmlformats.org/officeDocument/2006/relationships" xmlns:p="http://schemas.openxmlformats.org/presentationml/2006/main" showMasterSp="0">
   <p:cSld>
     <p:bg>
@@ -15517,110 +15804,6 @@
     <p:extLst>
       <p:ext uri="{BB962C8B-B14F-4D97-AF65-F5344CB8AC3E}">
         <p14:creationId xmlns:p14="http://schemas.microsoft.com/office/powerpoint/2010/main" val="149887682"/>
-      </p:ext>
-    </p:extLst>
-  </p:cSld>
-  <p:clrMapOvr>
-    <a:masterClrMapping/>
-  </p:clrMapOvr>
-</p:sld>
-</file>
-
-<file path=ppt/slides/slide9.xml><?xml version="1.0" encoding="utf-8"?>
-<p:sld xmlns:a="http://schemas.openxmlformats.org/drawingml/2006/main" xmlns:r="http://schemas.openxmlformats.org/officeDocument/2006/relationships" xmlns:p="http://schemas.openxmlformats.org/presentationml/2006/main" showMasterSp="0">
-  <p:cSld>
-    <p:bg>
-      <p:bgPr>
-        <a:solidFill>
-          <a:srgbClr val="CDF6F9"/>
-        </a:solidFill>
-        <a:effectLst/>
-      </p:bgPr>
-    </p:bg>
-    <p:spTree>
-      <p:nvGrpSpPr>
-        <p:cNvPr id="1" name="">
-          <a:extLst>
-            <a:ext uri="{FF2B5EF4-FFF2-40B4-BE49-F238E27FC236}">
-              <a16:creationId xmlns:a16="http://schemas.microsoft.com/office/drawing/2014/main" id="{3FBC84F0-4790-2E5C-BD77-A69CA39F653E}"/>
-            </a:ext>
-          </a:extLst>
-        </p:cNvPr>
-        <p:cNvGrpSpPr/>
-        <p:nvPr/>
-      </p:nvGrpSpPr>
-      <p:grpSpPr>
-        <a:xfrm>
-          <a:off x="0" y="0"/>
-          <a:ext cx="0" cy="0"/>
-          <a:chOff x="0" y="0"/>
-          <a:chExt cx="0" cy="0"/>
-        </a:xfrm>
-      </p:grpSpPr>
-      <p:pic>
-        <p:nvPicPr>
-          <p:cNvPr id="3" name="Picture 2">
-            <a:extLst>
-              <a:ext uri="{FF2B5EF4-FFF2-40B4-BE49-F238E27FC236}">
-                <a16:creationId xmlns:a16="http://schemas.microsoft.com/office/drawing/2014/main" id="{765F6181-9D1F-12D2-690A-B5E1843D8AAA}"/>
-              </a:ext>
-            </a:extLst>
-          </p:cNvPr>
-          <p:cNvPicPr>
-            <a:picLocks noChangeAspect="1"/>
-          </p:cNvPicPr>
-          <p:nvPr/>
-        </p:nvPicPr>
-        <p:blipFill>
-          <a:blip r:embed="rId3"/>
-          <a:stretch>
-            <a:fillRect/>
-          </a:stretch>
-        </p:blipFill>
-        <p:spPr>
-          <a:xfrm>
-            <a:off x="6505599" y="427712"/>
-            <a:ext cx="5106113" cy="4887007"/>
-          </a:xfrm>
-          <a:prstGeom prst="rect">
-            <a:avLst/>
-          </a:prstGeom>
-        </p:spPr>
-      </p:pic>
-      <p:pic>
-        <p:nvPicPr>
-          <p:cNvPr id="5" name="Picture 4">
-            <a:extLst>
-              <a:ext uri="{FF2B5EF4-FFF2-40B4-BE49-F238E27FC236}">
-                <a16:creationId xmlns:a16="http://schemas.microsoft.com/office/drawing/2014/main" id="{6A5C0805-4E2A-35B6-B6D6-E50B70D35153}"/>
-              </a:ext>
-            </a:extLst>
-          </p:cNvPr>
-          <p:cNvPicPr>
-            <a:picLocks noChangeAspect="1"/>
-          </p:cNvPicPr>
-          <p:nvPr/>
-        </p:nvPicPr>
-        <p:blipFill>
-          <a:blip r:embed="rId4"/>
-          <a:stretch>
-            <a:fillRect/>
-          </a:stretch>
-        </p:blipFill>
-        <p:spPr>
-          <a:xfrm>
-            <a:off x="856870" y="427712"/>
-            <a:ext cx="5449060" cy="5210902"/>
-          </a:xfrm>
-          <a:prstGeom prst="rect">
-            <a:avLst/>
-          </a:prstGeom>
-        </p:spPr>
-      </p:pic>
-    </p:spTree>
-    <p:extLst>
-      <p:ext uri="{BB962C8B-B14F-4D97-AF65-F5344CB8AC3E}">
-        <p14:creationId xmlns:p14="http://schemas.microsoft.com/office/powerpoint/2010/main" val="1025226808"/>
       </p:ext>
     </p:extLst>
   </p:cSld>

</xml_diff>